<commit_message>
Week 2 Multithreading interface, static
</commit_message>
<xml_diff>
--- a/PPT/Interface.pptx
+++ b/PPT/Interface.pptx
@@ -277,7 +277,7 @@
       </p15:sldGuideLst>
     </p:ext>
     <p:ext uri="GoogleSlidesCustomDataVersion2">
-      <go:slidesCustomData xmlns="" xmlns:mc="http://schemas.openxmlformats.org/markup-compatibility/2006" xmlns:mv="urn:schemas-microsoft-com:mac:vml" xmlns:c="http://schemas.openxmlformats.org/drawingml/2006/chart" xmlns:dgm="http://schemas.openxmlformats.org/drawingml/2006/diagram" xmlns:o="urn:schemas-microsoft-com:office:office" xmlns:v="urn:schemas-microsoft-com:vml" xmlns:pvml="urn:schemas-microsoft-com:office:powerpoint" xmlns:com="http://schemas.openxmlformats.org/drawingml/2006/compatibility" xmlns:p14="http://schemas.microsoft.com/office/powerpoint/2010/main" xmlns:p15="http://schemas.microsoft.com/office/powerpoint/2012/main" xmlns:ahyp="http://schemas.microsoft.com/office/drawing/2018/hyperlinkcolor" xmlns:go="http://customooxmlschemas.google.com/" r:id="rId24" roundtripDataSignature="AMtx7mhG7tsh/hV3Qck1HOTFv8rl+ed5vQ=="/>
+      <go:slidesCustomData xmlns:go="http://customooxmlschemas.google.com/" xmlns:ahyp="http://schemas.microsoft.com/office/drawing/2018/hyperlinkcolor" xmlns:p15="http://schemas.microsoft.com/office/powerpoint/2012/main" xmlns:p14="http://schemas.microsoft.com/office/powerpoint/2010/main" xmlns:com="http://schemas.openxmlformats.org/drawingml/2006/compatibility" xmlns:pvml="urn:schemas-microsoft-com:office:powerpoint" xmlns:v="urn:schemas-microsoft-com:vml" xmlns:o="urn:schemas-microsoft-com:office:office" xmlns:dgm="http://schemas.openxmlformats.org/drawingml/2006/diagram" xmlns:c="http://schemas.openxmlformats.org/drawingml/2006/chart" xmlns:mv="urn:schemas-microsoft-com:mac:vml" xmlns:mc="http://schemas.openxmlformats.org/markup-compatibility/2006" xmlns="" r:id="rId24" roundtripDataSignature="AMtx7mhG7tsh/hV3Qck1HOTFv8rl+ed5vQ=="/>
     </p:ext>
   </p:extLst>
 </p:presentation>
@@ -13553,7 +13553,12 @@
             <p:ph type="body" idx="1"/>
           </p:nvPr>
         </p:nvSpPr>
-        <p:spPr/>
+        <p:spPr>
+          <a:xfrm>
+            <a:off x="356616" y="1609344"/>
+            <a:ext cx="8229600" cy="4525963"/>
+          </a:xfrm>
+        </p:spPr>
         <p:txBody>
           <a:bodyPr>
             <a:normAutofit/>

</xml_diff>